<commit_message>
Release FreeConvert 0.18.0 with complete hover feedback and templates
</commit_message>
<xml_diff>
--- a/assets/templates/Presentation.pptx
+++ b/assets/templates/Presentation.pptx
@@ -3084,6 +3084,14 @@
 <file path=ppt/slides/slide1.xml><?xml version="1.0" encoding="utf-8"?>
 <p:sld xmlns:a="http://schemas.openxmlformats.org/drawingml/2006/main" xmlns:p="http://schemas.openxmlformats.org/presentationml/2006/main" xmlns:r="http://schemas.openxmlformats.org/officeDocument/2006/relationships">
   <p:cSld>
+    <p:bg>
+      <p:bgPr>
+        <a:solidFill>
+          <a:srgbClr val="0B0B0B"/>
+        </a:solidFill>
+        <a:effectLst/>
+      </p:bgPr>
+    </p:bg>
     <p:spTree>
       <p:nvGrpSpPr>
         <p:cNvPr id="1" name=""/>
@@ -3106,6 +3114,14 @@
           <a:bodyPr/>
           <a:lstStyle/>
           <a:p>
+            <a:pPr>
+              <a:defRPr sz="3200" b="1">
+                <a:solidFill>
+                  <a:srgbClr val="FFDD22"/>
+                </a:solidFill>
+                <a:latin typeface="Calibri"/>
+              </a:defRPr>
+            </a:pPr>
             <a:r>
               <a:t>Presentation title</a:t>
             </a:r>
@@ -3127,6 +3143,14 @@
           <a:bodyPr/>
           <a:lstStyle/>
           <a:p>
+            <a:pPr>
+              <a:defRPr sz="2000" b="0">
+                <a:solidFill>
+                  <a:srgbClr val="F2F2ED"/>
+                </a:solidFill>
+                <a:latin typeface="Calibri"/>
+              </a:defRPr>
+            </a:pPr>
             <a:r>
               <a:t>Subtitle · Presenter</a:t>
             </a:r>
@@ -3144,6 +3168,14 @@
 <file path=ppt/slides/slide2.xml><?xml version="1.0" encoding="utf-8"?>
 <p:sld xmlns:a="http://schemas.openxmlformats.org/drawingml/2006/main" xmlns:p="http://schemas.openxmlformats.org/presentationml/2006/main" xmlns:r="http://schemas.openxmlformats.org/officeDocument/2006/relationships">
   <p:cSld>
+    <p:bg>
+      <p:bgPr>
+        <a:solidFill>
+          <a:srgbClr val="0B0B0B"/>
+        </a:solidFill>
+        <a:effectLst/>
+      </p:bgPr>
+    </p:bg>
     <p:spTree>
       <p:nvGrpSpPr>
         <p:cNvPr id="1" name=""/>
@@ -3166,6 +3198,14 @@
           <a:bodyPr/>
           <a:lstStyle/>
           <a:p>
+            <a:pPr>
+              <a:defRPr sz="3200" b="1">
+                <a:solidFill>
+                  <a:srgbClr val="FFDD22"/>
+                </a:solidFill>
+                <a:latin typeface="Calibri"/>
+              </a:defRPr>
+            </a:pPr>
             <a:r>
               <a:t>Agenda</a:t>
             </a:r>
@@ -3187,16 +3227,40 @@
           <a:bodyPr/>
           <a:lstStyle/>
           <a:p>
+            <a:pPr>
+              <a:defRPr sz="2000" b="0">
+                <a:solidFill>
+                  <a:srgbClr val="F2F2ED"/>
+                </a:solidFill>
+                <a:latin typeface="Calibri"/>
+              </a:defRPr>
+            </a:pPr>
             <a:r>
               <a:t>Context</a:t>
             </a:r>
           </a:p>
           <a:p>
+            <a:pPr>
+              <a:defRPr sz="2000" b="0">
+                <a:solidFill>
+                  <a:srgbClr val="F2F2ED"/>
+                </a:solidFill>
+                <a:latin typeface="Calibri"/>
+              </a:defRPr>
+            </a:pPr>
             <a:r>
               <a:t>Key points</a:t>
             </a:r>
           </a:p>
           <a:p>
+            <a:pPr>
+              <a:defRPr sz="2000" b="0">
+                <a:solidFill>
+                  <a:srgbClr val="F2F2ED"/>
+                </a:solidFill>
+                <a:latin typeface="Calibri"/>
+              </a:defRPr>
+            </a:pPr>
             <a:r>
               <a:t>Next steps</a:t>
             </a:r>
@@ -3214,6 +3278,14 @@
 <file path=ppt/slides/slide3.xml><?xml version="1.0" encoding="utf-8"?>
 <p:sld xmlns:a="http://schemas.openxmlformats.org/drawingml/2006/main" xmlns:p="http://schemas.openxmlformats.org/presentationml/2006/main" xmlns:r="http://schemas.openxmlformats.org/officeDocument/2006/relationships">
   <p:cSld>
+    <p:bg>
+      <p:bgPr>
+        <a:solidFill>
+          <a:srgbClr val="0B0B0B"/>
+        </a:solidFill>
+        <a:effectLst/>
+      </p:bgPr>
+    </p:bg>
     <p:spTree>
       <p:nvGrpSpPr>
         <p:cNvPr id="1" name=""/>
@@ -3236,6 +3308,14 @@
           <a:bodyPr/>
           <a:lstStyle/>
           <a:p>
+            <a:pPr>
+              <a:defRPr sz="3200" b="1">
+                <a:solidFill>
+                  <a:srgbClr val="FFDD22"/>
+                </a:solidFill>
+                <a:latin typeface="Calibri"/>
+              </a:defRPr>
+            </a:pPr>
             <a:r>
               <a:t>Key points</a:t>
             </a:r>
@@ -3257,6 +3337,14 @@
           <a:bodyPr/>
           <a:lstStyle/>
           <a:p>
+            <a:pPr>
+              <a:defRPr sz="2000" b="0">
+                <a:solidFill>
+                  <a:srgbClr val="F2F2ED"/>
+                </a:solidFill>
+                <a:latin typeface="Calibri"/>
+              </a:defRPr>
+            </a:pPr>
             <a:r>
               <a:t>Add your main message here.</a:t>
             </a:r>
@@ -3274,6 +3362,14 @@
 <file path=ppt/slides/slide4.xml><?xml version="1.0" encoding="utf-8"?>
 <p:sld xmlns:a="http://schemas.openxmlformats.org/drawingml/2006/main" xmlns:p="http://schemas.openxmlformats.org/presentationml/2006/main" xmlns:r="http://schemas.openxmlformats.org/officeDocument/2006/relationships">
   <p:cSld>
+    <p:bg>
+      <p:bgPr>
+        <a:solidFill>
+          <a:srgbClr val="0B0B0B"/>
+        </a:solidFill>
+        <a:effectLst/>
+      </p:bgPr>
+    </p:bg>
     <p:spTree>
       <p:nvGrpSpPr>
         <p:cNvPr id="1" name=""/>
@@ -3296,6 +3392,14 @@
           <a:bodyPr/>
           <a:lstStyle/>
           <a:p>
+            <a:pPr>
+              <a:defRPr sz="3200" b="1">
+                <a:solidFill>
+                  <a:srgbClr val="FFDD22"/>
+                </a:solidFill>
+                <a:latin typeface="Calibri"/>
+              </a:defRPr>
+            </a:pPr>
             <a:r>
               <a:t>Next steps</a:t>
             </a:r>
@@ -3317,6 +3421,14 @@
           <a:bodyPr/>
           <a:lstStyle/>
           <a:p>
+            <a:pPr>
+              <a:defRPr sz="2000" b="0">
+                <a:solidFill>
+                  <a:srgbClr val="F2F2ED"/>
+                </a:solidFill>
+                <a:latin typeface="Calibri"/>
+              </a:defRPr>
+            </a:pPr>
             <a:r>
               <a:t>Action · Owner · Date</a:t>
             </a:r>

</xml_diff>